<commit_message>
docs(pptx): use Arial so the deck renders sans-serif on macOS too
Segoe UI is Windows-only and fell back to a serif (Times) on macOS/Keynote.
Switch the generated deck to Arial (present on macOS and Windows) and use
Courier New for the code run. Also resolve the default output path relative
to the script.

Co-Authored-By: Claude Opus 4.8 (1M context) <noreply@anthropic.com>
</commit_message>
<xml_diff>
--- a/docs/presentation/smart-data-dico-bnp.pptx
+++ b/docs/presentation/smart-data-dico-bnp.pptx
@@ -1370,9 +1370,9 @@
                 <a:solidFill>
                   <a:srgbClr val="CFEEDE"/>
                 </a:solidFill>
-                <a:latin typeface="Segoe UI" pitchFamily="34" charset="0"/>
-                <a:ea typeface="Segoe UI" pitchFamily="34" charset="-122"/>
-                <a:cs typeface="Segoe UI" pitchFamily="34" charset="-120"/>
+                <a:latin typeface="Arial" pitchFamily="34" charset="0"/>
+                <a:ea typeface="Arial" pitchFamily="34" charset="-122"/>
+                <a:cs typeface="Arial" pitchFamily="34" charset="-120"/>
               </a:rPr>
               <a:t>DATA MODELLING &amp; GOVERNANCE PLATFORM</a:t>
             </a:r>
@@ -1409,9 +1409,9 @@
                 <a:solidFill>
                   <a:srgbClr val="FFFFFF"/>
                 </a:solidFill>
-                <a:latin typeface="Segoe UI" pitchFamily="34" charset="0"/>
-                <a:ea typeface="Segoe UI" pitchFamily="34" charset="-122"/>
-                <a:cs typeface="Segoe UI" pitchFamily="34" charset="-120"/>
+                <a:latin typeface="Arial" pitchFamily="34" charset="0"/>
+                <a:ea typeface="Arial" pitchFamily="34" charset="-122"/>
+                <a:cs typeface="Arial" pitchFamily="34" charset="-120"/>
               </a:rPr>
               <a:t>Smart Data Dictionary</a:t>
             </a:r>
@@ -1451,9 +1451,9 @@
                 <a:solidFill>
                   <a:srgbClr val="EAFFF5"/>
                 </a:solidFill>
-                <a:latin typeface="Segoe UI" pitchFamily="34" charset="0"/>
-                <a:ea typeface="Segoe UI" pitchFamily="34" charset="-122"/>
-                <a:cs typeface="Segoe UI" pitchFamily="34" charset="-120"/>
+                <a:latin typeface="Arial" pitchFamily="34" charset="0"/>
+                <a:ea typeface="Arial" pitchFamily="34" charset="-122"/>
+                <a:cs typeface="Arial" pitchFamily="34" charset="-120"/>
               </a:rPr>
               <a:t>See the whole system — capture the data model, the use cases, and the processes behind it, in one living, shared, governed model.</a:t>
             </a:r>
@@ -1516,9 +1516,9 @@
                 <a:solidFill>
                   <a:srgbClr val="FFFFFF"/>
                 </a:solidFill>
-                <a:latin typeface="Segoe UI" pitchFamily="34" charset="0"/>
-                <a:ea typeface="Segoe UI" pitchFamily="34" charset="-122"/>
-                <a:cs typeface="Segoe UI" pitchFamily="34" charset="-120"/>
+                <a:latin typeface="Arial" pitchFamily="34" charset="0"/>
+                <a:ea typeface="Arial" pitchFamily="34" charset="-122"/>
+                <a:cs typeface="Arial" pitchFamily="34" charset="-120"/>
               </a:rPr>
               <a:t>Prepared for BNP Paribas</a:t>
             </a:r>
@@ -1555,9 +1555,9 @@
                 <a:solidFill>
                   <a:srgbClr val="DFF7EC"/>
                 </a:solidFill>
-                <a:latin typeface="Segoe UI" pitchFamily="34" charset="0"/>
-                <a:ea typeface="Segoe UI" pitchFamily="34" charset="-122"/>
-                <a:cs typeface="Segoe UI" pitchFamily="34" charset="-120"/>
+                <a:latin typeface="Arial" pitchFamily="34" charset="0"/>
+                <a:ea typeface="Arial" pitchFamily="34" charset="-122"/>
+                <a:cs typeface="Arial" pitchFamily="34" charset="-120"/>
               </a:rPr>
               <a:t>Visibility into complex systems</a:t>
             </a:r>
@@ -1626,9 +1626,9 @@
                 <a:solidFill>
                   <a:srgbClr val="00965E"/>
                 </a:solidFill>
-                <a:latin typeface="Segoe UI" pitchFamily="34" charset="0"/>
-                <a:ea typeface="Segoe UI" pitchFamily="34" charset="-122"/>
-                <a:cs typeface="Segoe UI" pitchFamily="34" charset="-120"/>
+                <a:latin typeface="Arial" pitchFamily="34" charset="0"/>
+                <a:ea typeface="Arial" pitchFamily="34" charset="-122"/>
+                <a:cs typeface="Arial" pitchFamily="34" charset="-120"/>
               </a:rPr>
               <a:t>THE CHALLENGE &amp; THE GOAL</a:t>
             </a:r>
@@ -1665,9 +1665,9 @@
                 <a:solidFill>
                   <a:srgbClr val="15241D"/>
                 </a:solidFill>
-                <a:latin typeface="Segoe UI" pitchFamily="34" charset="0"/>
-                <a:ea typeface="Segoe UI" pitchFamily="34" charset="-122"/>
-                <a:cs typeface="Segoe UI" pitchFamily="34" charset="-120"/>
+                <a:latin typeface="Arial" pitchFamily="34" charset="0"/>
+                <a:ea typeface="Arial" pitchFamily="34" charset="-122"/>
+                <a:cs typeface="Arial" pitchFamily="34" charset="-120"/>
               </a:rPr>
               <a:t>Complex systems lose their shared picture</a:t>
             </a:r>
@@ -1704,9 +1704,9 @@
                 <a:solidFill>
                   <a:srgbClr val="5B6B63"/>
                 </a:solidFill>
-                <a:latin typeface="Segoe UI" pitchFamily="34" charset="0"/>
-                <a:ea typeface="Segoe UI" pitchFamily="34" charset="-122"/>
-                <a:cs typeface="Segoe UI" pitchFamily="34" charset="-120"/>
+                <a:latin typeface="Arial" pitchFamily="34" charset="0"/>
+                <a:ea typeface="Arial" pitchFamily="34" charset="-122"/>
+                <a:cs typeface="Arial" pitchFamily="34" charset="-120"/>
               </a:rPr>
               <a:t>TODAY</a:t>
             </a:r>
@@ -1743,9 +1743,9 @@
                 <a:solidFill>
                   <a:srgbClr val="00965E"/>
                 </a:solidFill>
-                <a:latin typeface="Segoe UI" pitchFamily="34" charset="0"/>
-                <a:ea typeface="Segoe UI" pitchFamily="34" charset="-122"/>
-                <a:cs typeface="Segoe UI" pitchFamily="34" charset="-120"/>
+                <a:latin typeface="Arial" pitchFamily="34" charset="0"/>
+                <a:ea typeface="Arial" pitchFamily="34" charset="-122"/>
+                <a:cs typeface="Arial" pitchFamily="34" charset="-120"/>
               </a:rPr>
               <a:t>WITH SMART DATA DICTIONARY</a:t>
             </a:r>
@@ -1789,9 +1789,9 @@
                 <a:solidFill>
                   <a:srgbClr val="5B6B63"/>
                 </a:solidFill>
-                <a:latin typeface="Segoe UI" pitchFamily="34" charset="0"/>
-                <a:ea typeface="Segoe UI" pitchFamily="34" charset="-122"/>
-                <a:cs typeface="Segoe UI" pitchFamily="34" charset="-120"/>
+                <a:latin typeface="Arial" pitchFamily="34" charset="0"/>
+                <a:ea typeface="Arial" pitchFamily="34" charset="-122"/>
+                <a:cs typeface="Arial" pitchFamily="34" charset="-120"/>
               </a:rPr>
               <a:t>Knowledge scattered across services, schemas, slides &amp; people</a:t>
             </a:r>
@@ -1813,9 +1813,9 @@
                 <a:solidFill>
                   <a:srgbClr val="5B6B63"/>
                 </a:solidFill>
-                <a:latin typeface="Segoe UI" pitchFamily="34" charset="0"/>
-                <a:ea typeface="Segoe UI" pitchFamily="34" charset="-122"/>
-                <a:cs typeface="Segoe UI" pitchFamily="34" charset="-120"/>
+                <a:latin typeface="Arial" pitchFamily="34" charset="0"/>
+                <a:ea typeface="Arial" pitchFamily="34" charset="-122"/>
+                <a:cs typeface="Arial" pitchFamily="34" charset="-120"/>
               </a:rPr>
               <a:t>No single source of truth — diagrams drift from reality</a:t>
             </a:r>
@@ -1837,9 +1837,9 @@
                 <a:solidFill>
                   <a:srgbClr val="5B6B63"/>
                 </a:solidFill>
-                <a:latin typeface="Segoe UI" pitchFamily="34" charset="0"/>
-                <a:ea typeface="Segoe UI" pitchFamily="34" charset="-122"/>
-                <a:cs typeface="Segoe UI" pitchFamily="34" charset="-120"/>
+                <a:latin typeface="Arial" pitchFamily="34" charset="0"/>
+                <a:ea typeface="Arial" pitchFamily="34" charset="-122"/>
+                <a:cs typeface="Arial" pitchFamily="34" charset="-120"/>
               </a:rPr>
               <a:t>Hard to see how data, rules &amp; lifecycles connect</a:t>
             </a:r>
@@ -1861,9 +1861,9 @@
                 <a:solidFill>
                   <a:srgbClr val="5B6B63"/>
                 </a:solidFill>
-                <a:latin typeface="Segoe UI" pitchFamily="34" charset="0"/>
-                <a:ea typeface="Segoe UI" pitchFamily="34" charset="-122"/>
-                <a:cs typeface="Segoe UI" pitchFamily="34" charset="-120"/>
+                <a:latin typeface="Arial" pitchFamily="34" charset="0"/>
+                <a:ea typeface="Arial" pitchFamily="34" charset="-122"/>
+                <a:cs typeface="Arial" pitchFamily="34" charset="-120"/>
               </a:rPr>
               <a:t>Governance &amp; impact analysis are manual and slow</a:t>
             </a:r>
@@ -1907,9 +1907,9 @@
                 <a:solidFill>
                   <a:srgbClr val="15241D"/>
                 </a:solidFill>
-                <a:latin typeface="Segoe UI" pitchFamily="34" charset="0"/>
-                <a:ea typeface="Segoe UI" pitchFamily="34" charset="-122"/>
-                <a:cs typeface="Segoe UI" pitchFamily="34" charset="-120"/>
+                <a:latin typeface="Arial" pitchFamily="34" charset="0"/>
+                <a:ea typeface="Arial" pitchFamily="34" charset="-122"/>
+                <a:cs typeface="Arial" pitchFamily="34" charset="-120"/>
               </a:rPr>
               <a:t>One living model of the whole landscape</a:t>
             </a:r>
@@ -1931,9 +1931,9 @@
                 <a:solidFill>
                   <a:srgbClr val="15241D"/>
                 </a:solidFill>
-                <a:latin typeface="Segoe UI" pitchFamily="34" charset="0"/>
-                <a:ea typeface="Segoe UI" pitchFamily="34" charset="-122"/>
-                <a:cs typeface="Segoe UI" pitchFamily="34" charset="-120"/>
+                <a:latin typeface="Arial" pitchFamily="34" charset="0"/>
+                <a:ea typeface="Arial" pitchFamily="34" charset="-122"/>
+                <a:cs typeface="Arial" pitchFamily="34" charset="-120"/>
               </a:rPr>
               <a:t>Version-controlled in git — auditable, reviewable, shareable</a:t>
             </a:r>
@@ -1955,9 +1955,9 @@
                 <a:solidFill>
                   <a:srgbClr val="15241D"/>
                 </a:solidFill>
-                <a:latin typeface="Segoe UI" pitchFamily="34" charset="0"/>
-                <a:ea typeface="Segoe UI" pitchFamily="34" charset="-122"/>
-                <a:cs typeface="Segoe UI" pitchFamily="34" charset="-120"/>
+                <a:latin typeface="Arial" pitchFamily="34" charset="0"/>
+                <a:ea typeface="Arial" pitchFamily="34" charset="-122"/>
+                <a:cs typeface="Arial" pitchFamily="34" charset="-120"/>
               </a:rPr>
               <a:t>Data, business rules and processes captured together</a:t>
             </a:r>
@@ -1979,9 +1979,9 @@
                 <a:solidFill>
                   <a:srgbClr val="15241D"/>
                 </a:solidFill>
-                <a:latin typeface="Segoe UI" pitchFamily="34" charset="0"/>
-                <a:ea typeface="Segoe UI" pitchFamily="34" charset="-122"/>
-                <a:cs typeface="Segoe UI" pitchFamily="34" charset="-120"/>
+                <a:latin typeface="Arial" pitchFamily="34" charset="0"/>
+                <a:ea typeface="Arial" pitchFamily="34" charset="-122"/>
+                <a:cs typeface="Arial" pitchFamily="34" charset="-120"/>
               </a:rPr>
               <a:t>Visibility &amp; impact at a glance, for every stakeholder</a:t>
             </a:r>
@@ -2061,9 +2061,9 @@
                 <a:solidFill>
                   <a:srgbClr val="15241D"/>
                 </a:solidFill>
-                <a:latin typeface="Segoe UI" pitchFamily="34" charset="0"/>
-                <a:ea typeface="Segoe UI" pitchFamily="34" charset="-122"/>
-                <a:cs typeface="Segoe UI" pitchFamily="34" charset="-120"/>
+                <a:latin typeface="Arial" pitchFamily="34" charset="0"/>
+                <a:ea typeface="Arial" pitchFamily="34" charset="-122"/>
+                <a:cs typeface="Arial" pitchFamily="34" charset="-120"/>
               </a:rPr>
               <a:t>Smart Data Dictionary</a:t>
             </a:r>
@@ -2075,9 +2075,9 @@
                 <a:solidFill>
                   <a:srgbClr val="5B6B63"/>
                 </a:solidFill>
-                <a:latin typeface="Segoe UI" pitchFamily="34" charset="0"/>
-                <a:ea typeface="Segoe UI" pitchFamily="34" charset="-122"/>
-                <a:cs typeface="Segoe UI" pitchFamily="34" charset="-120"/>
+                <a:latin typeface="Arial" pitchFamily="34" charset="0"/>
+                <a:ea typeface="Arial" pitchFamily="34" charset="-122"/>
+                <a:cs typeface="Arial" pitchFamily="34" charset="-120"/>
               </a:rPr>
               <a:t>  ·  Prepared for BNP Paribas</a:t>
             </a:r>
@@ -2114,9 +2114,9 @@
                 <a:solidFill>
                   <a:srgbClr val="5B6B63"/>
                 </a:solidFill>
-                <a:latin typeface="Segoe UI" pitchFamily="34" charset="0"/>
-                <a:ea typeface="Segoe UI" pitchFamily="34" charset="-122"/>
-                <a:cs typeface="Segoe UI" pitchFamily="34" charset="-120"/>
+                <a:latin typeface="Arial" pitchFamily="34" charset="0"/>
+                <a:ea typeface="Arial" pitchFamily="34" charset="-122"/>
+                <a:cs typeface="Arial" pitchFamily="34" charset="-120"/>
               </a:rPr>
               <a:t>2 / 5</a:t>
             </a:r>
@@ -2185,9 +2185,9 @@
                 <a:solidFill>
                   <a:srgbClr val="00965E"/>
                 </a:solidFill>
-                <a:latin typeface="Segoe UI" pitchFamily="34" charset="0"/>
-                <a:ea typeface="Segoe UI" pitchFamily="34" charset="-122"/>
-                <a:cs typeface="Segoe UI" pitchFamily="34" charset="-120"/>
+                <a:latin typeface="Arial" pitchFamily="34" charset="0"/>
+                <a:ea typeface="Arial" pitchFamily="34" charset="-122"/>
+                <a:cs typeface="Arial" pitchFamily="34" charset="-120"/>
               </a:rPr>
               <a:t>ONE MODEL, THREE CONNECTED FACETS</a:t>
             </a:r>
@@ -2224,9 +2224,9 @@
                 <a:solidFill>
                   <a:srgbClr val="15241D"/>
                 </a:solidFill>
-                <a:latin typeface="Segoe UI" pitchFamily="34" charset="0"/>
-                <a:ea typeface="Segoe UI" pitchFamily="34" charset="-122"/>
-                <a:cs typeface="Segoe UI" pitchFamily="34" charset="-120"/>
+                <a:latin typeface="Arial" pitchFamily="34" charset="0"/>
+                <a:ea typeface="Arial" pitchFamily="34" charset="-122"/>
+                <a:cs typeface="Arial" pitchFamily="34" charset="-120"/>
               </a:rPr>
               <a:t>Capture the full picture of a system</a:t>
             </a:r>
@@ -2266,9 +2266,9 @@
                 <a:solidFill>
                   <a:srgbClr val="5B6B63"/>
                 </a:solidFill>
-                <a:latin typeface="Segoe UI" pitchFamily="34" charset="0"/>
-                <a:ea typeface="Segoe UI" pitchFamily="34" charset="-122"/>
-                <a:cs typeface="Segoe UI" pitchFamily="34" charset="-120"/>
+                <a:latin typeface="Arial" pitchFamily="34" charset="0"/>
+                <a:ea typeface="Arial" pitchFamily="34" charset="-122"/>
+                <a:cs typeface="Arial" pitchFamily="34" charset="-120"/>
               </a:rPr>
               <a:t>Most tools stop at boxes and lines. Smart Data Dictionary models what the data is, how the business uses it, and how it behaves over time.</a:t>
             </a:r>
@@ -2374,9 +2374,9 @@
                 <a:solidFill>
                   <a:srgbClr val="FFFFFF"/>
                 </a:solidFill>
-                <a:latin typeface="Segoe UI" pitchFamily="34" charset="0"/>
-                <a:ea typeface="Segoe UI" pitchFamily="34" charset="-122"/>
-                <a:cs typeface="Segoe UI" pitchFamily="34" charset="-120"/>
+                <a:latin typeface="Arial" pitchFamily="34" charset="0"/>
+                <a:ea typeface="Arial" pitchFamily="34" charset="-122"/>
+                <a:cs typeface="Arial" pitchFamily="34" charset="-120"/>
               </a:rPr>
               <a:t>◧</a:t>
             </a:r>
@@ -2413,9 +2413,9 @@
                 <a:solidFill>
                   <a:srgbClr val="15241D"/>
                 </a:solidFill>
-                <a:latin typeface="Segoe UI" pitchFamily="34" charset="0"/>
-                <a:ea typeface="Segoe UI" pitchFamily="34" charset="-122"/>
-                <a:cs typeface="Segoe UI" pitchFamily="34" charset="-120"/>
+                <a:latin typeface="Arial" pitchFamily="34" charset="0"/>
+                <a:ea typeface="Arial" pitchFamily="34" charset="-122"/>
+                <a:cs typeface="Arial" pitchFamily="34" charset="-120"/>
               </a:rPr>
               <a:t>Data model</a:t>
             </a:r>
@@ -2455,9 +2455,9 @@
                 <a:solidFill>
                   <a:srgbClr val="5B6B63"/>
                 </a:solidFill>
-                <a:latin typeface="Segoe UI" pitchFamily="34" charset="0"/>
-                <a:ea typeface="Segoe UI" pitchFamily="34" charset="-122"/>
-                <a:cs typeface="Segoe UI" pitchFamily="34" charset="-120"/>
+                <a:latin typeface="Arial" pitchFamily="34" charset="0"/>
+                <a:ea typeface="Arial" pitchFamily="34" charset="-122"/>
+                <a:cs typeface="Arial" pitchFamily="34" charset="-120"/>
               </a:rPr>
               <a:t>Packages, entities &amp; typed attributes with validation, relationships, DB-enforced constraints and reusable derived types.</a:t>
             </a:r>
@@ -2494,9 +2494,9 @@
                 <a:solidFill>
                   <a:srgbClr val="007348"/>
                 </a:solidFill>
-                <a:latin typeface="Segoe UI" pitchFamily="34" charset="0"/>
-                <a:ea typeface="Segoe UI" pitchFamily="34" charset="-122"/>
-                <a:cs typeface="Segoe UI" pitchFamily="34" charset="-120"/>
+                <a:latin typeface="Arial" pitchFamily="34" charset="0"/>
+                <a:ea typeface="Arial" pitchFamily="34" charset="-122"/>
+                <a:cs typeface="Arial" pitchFamily="34" charset="-120"/>
               </a:rPr>
               <a:t>  Entities  </a:t>
             </a:r>
@@ -2508,9 +2508,9 @@
                 <a:solidFill>
                   <a:srgbClr val="000000"/>
                 </a:solidFill>
-                <a:latin typeface="Segoe UI" pitchFamily="34" charset="0"/>
-                <a:ea typeface="Segoe UI" pitchFamily="34" charset="-122"/>
-                <a:cs typeface="Segoe UI" pitchFamily="34" charset="-120"/>
+                <a:latin typeface="Arial" pitchFamily="34" charset="0"/>
+                <a:ea typeface="Arial" pitchFamily="34" charset="-122"/>
+                <a:cs typeface="Arial" pitchFamily="34" charset="-120"/>
               </a:rPr>
               <a:t> </a:t>
             </a:r>
@@ -2522,9 +2522,9 @@
                 <a:solidFill>
                   <a:srgbClr val="007348"/>
                 </a:solidFill>
-                <a:latin typeface="Segoe UI" pitchFamily="34" charset="0"/>
-                <a:ea typeface="Segoe UI" pitchFamily="34" charset="-122"/>
-                <a:cs typeface="Segoe UI" pitchFamily="34" charset="-120"/>
+                <a:latin typeface="Arial" pitchFamily="34" charset="0"/>
+                <a:ea typeface="Arial" pitchFamily="34" charset="-122"/>
+                <a:cs typeface="Arial" pitchFamily="34" charset="-120"/>
               </a:rPr>
               <a:t>  Relationships  </a:t>
             </a:r>
@@ -2536,9 +2536,9 @@
                 <a:solidFill>
                   <a:srgbClr val="000000"/>
                 </a:solidFill>
-                <a:latin typeface="Segoe UI" pitchFamily="34" charset="0"/>
-                <a:ea typeface="Segoe UI" pitchFamily="34" charset="-122"/>
-                <a:cs typeface="Segoe UI" pitchFamily="34" charset="-120"/>
+                <a:latin typeface="Arial" pitchFamily="34" charset="0"/>
+                <a:ea typeface="Arial" pitchFamily="34" charset="-122"/>
+                <a:cs typeface="Arial" pitchFamily="34" charset="-120"/>
               </a:rPr>
               <a:t> </a:t>
             </a:r>
@@ -2550,9 +2550,9 @@
                 <a:solidFill>
                   <a:srgbClr val="007348"/>
                 </a:solidFill>
-                <a:latin typeface="Segoe UI" pitchFamily="34" charset="0"/>
-                <a:ea typeface="Segoe UI" pitchFamily="34" charset="-122"/>
-                <a:cs typeface="Segoe UI" pitchFamily="34" charset="-120"/>
+                <a:latin typeface="Arial" pitchFamily="34" charset="0"/>
+                <a:ea typeface="Arial" pitchFamily="34" charset="-122"/>
+                <a:cs typeface="Arial" pitchFamily="34" charset="-120"/>
               </a:rPr>
               <a:t>  Validation  </a:t>
             </a:r>
@@ -2564,9 +2564,9 @@
                 <a:solidFill>
                   <a:srgbClr val="000000"/>
                 </a:solidFill>
-                <a:latin typeface="Segoe UI" pitchFamily="34" charset="0"/>
-                <a:ea typeface="Segoe UI" pitchFamily="34" charset="-122"/>
-                <a:cs typeface="Segoe UI" pitchFamily="34" charset="-120"/>
+                <a:latin typeface="Arial" pitchFamily="34" charset="0"/>
+                <a:ea typeface="Arial" pitchFamily="34" charset="-122"/>
+                <a:cs typeface="Arial" pitchFamily="34" charset="-120"/>
               </a:rPr>
               <a:t> </a:t>
             </a:r>
@@ -2578,9 +2578,9 @@
                 <a:solidFill>
                   <a:srgbClr val="007348"/>
                 </a:solidFill>
-                <a:latin typeface="Segoe UI" pitchFamily="34" charset="0"/>
-                <a:ea typeface="Segoe UI" pitchFamily="34" charset="-122"/>
-                <a:cs typeface="Segoe UI" pitchFamily="34" charset="-120"/>
+                <a:latin typeface="Arial" pitchFamily="34" charset="0"/>
+                <a:ea typeface="Arial" pitchFamily="34" charset="-122"/>
+                <a:cs typeface="Arial" pitchFamily="34" charset="-120"/>
               </a:rPr>
               <a:t>  Constraints  </a:t>
             </a:r>
@@ -2686,9 +2686,9 @@
                 <a:solidFill>
                   <a:srgbClr val="FFFFFF"/>
                 </a:solidFill>
-                <a:latin typeface="Segoe UI" pitchFamily="34" charset="0"/>
-                <a:ea typeface="Segoe UI" pitchFamily="34" charset="-122"/>
-                <a:cs typeface="Segoe UI" pitchFamily="34" charset="-120"/>
+                <a:latin typeface="Arial" pitchFamily="34" charset="0"/>
+                <a:ea typeface="Arial" pitchFamily="34" charset="-122"/>
+                <a:cs typeface="Arial" pitchFamily="34" charset="-120"/>
               </a:rPr>
               <a:t>★</a:t>
             </a:r>
@@ -2725,9 +2725,9 @@
                 <a:solidFill>
                   <a:srgbClr val="15241D"/>
                 </a:solidFill>
-                <a:latin typeface="Segoe UI" pitchFamily="34" charset="0"/>
-                <a:ea typeface="Segoe UI" pitchFamily="34" charset="-122"/>
-                <a:cs typeface="Segoe UI" pitchFamily="34" charset="-120"/>
+                <a:latin typeface="Arial" pitchFamily="34" charset="0"/>
+                <a:ea typeface="Arial" pitchFamily="34" charset="-122"/>
+                <a:cs typeface="Arial" pitchFamily="34" charset="-120"/>
               </a:rPr>
               <a:t>Use cases &amp; views</a:t>
             </a:r>
@@ -2767,9 +2767,9 @@
                 <a:solidFill>
                   <a:srgbClr val="5B6B63"/>
                 </a:solidFill>
-                <a:latin typeface="Segoe UI" pitchFamily="34" charset="0"/>
-                <a:ea typeface="Segoe UI" pitchFamily="34" charset="-122"/>
-                <a:cs typeface="Segoe UI" pitchFamily="34" charset="-120"/>
+                <a:latin typeface="Arial" pitchFamily="34" charset="0"/>
+                <a:ea typeface="Arial" pitchFamily="34" charset="-122"/>
+                <a:cs typeface="Arial" pitchFamily="34" charset="-120"/>
               </a:rPr>
               <a:t>Business "cases" and perspectives resolve a focused sub-model from any starting point — the view each audience needs.</a:t>
             </a:r>
@@ -2806,9 +2806,9 @@
                 <a:solidFill>
                   <a:srgbClr val="007348"/>
                 </a:solidFill>
-                <a:latin typeface="Segoe UI" pitchFamily="34" charset="0"/>
-                <a:ea typeface="Segoe UI" pitchFamily="34" charset="-122"/>
-                <a:cs typeface="Segoe UI" pitchFamily="34" charset="-120"/>
+                <a:latin typeface="Arial" pitchFamily="34" charset="0"/>
+                <a:ea typeface="Arial" pitchFamily="34" charset="-122"/>
+                <a:cs typeface="Arial" pitchFamily="34" charset="-120"/>
               </a:rPr>
               <a:t>  Cases  </a:t>
             </a:r>
@@ -2820,9 +2820,9 @@
                 <a:solidFill>
                   <a:srgbClr val="000000"/>
                 </a:solidFill>
-                <a:latin typeface="Segoe UI" pitchFamily="34" charset="0"/>
-                <a:ea typeface="Segoe UI" pitchFamily="34" charset="-122"/>
-                <a:cs typeface="Segoe UI" pitchFamily="34" charset="-120"/>
+                <a:latin typeface="Arial" pitchFamily="34" charset="0"/>
+                <a:ea typeface="Arial" pitchFamily="34" charset="-122"/>
+                <a:cs typeface="Arial" pitchFamily="34" charset="-120"/>
               </a:rPr>
               <a:t> </a:t>
             </a:r>
@@ -2834,9 +2834,9 @@
                 <a:solidFill>
                   <a:srgbClr val="007348"/>
                 </a:solidFill>
-                <a:latin typeface="Segoe UI" pitchFamily="34" charset="0"/>
-                <a:ea typeface="Segoe UI" pitchFamily="34" charset="-122"/>
-                <a:cs typeface="Segoe UI" pitchFamily="34" charset="-120"/>
+                <a:latin typeface="Arial" pitchFamily="34" charset="0"/>
+                <a:ea typeface="Arial" pitchFamily="34" charset="-122"/>
+                <a:cs typeface="Arial" pitchFamily="34" charset="-120"/>
               </a:rPr>
               <a:t>  Perspectives  </a:t>
             </a:r>
@@ -2848,9 +2848,9 @@
                 <a:solidFill>
                   <a:srgbClr val="000000"/>
                 </a:solidFill>
-                <a:latin typeface="Segoe UI" pitchFamily="34" charset="0"/>
-                <a:ea typeface="Segoe UI" pitchFamily="34" charset="-122"/>
-                <a:cs typeface="Segoe UI" pitchFamily="34" charset="-120"/>
+                <a:latin typeface="Arial" pitchFamily="34" charset="0"/>
+                <a:ea typeface="Arial" pitchFamily="34" charset="-122"/>
+                <a:cs typeface="Arial" pitchFamily="34" charset="-120"/>
               </a:rPr>
               <a:t> </a:t>
             </a:r>
@@ -2862,9 +2862,9 @@
                 <a:solidFill>
                   <a:srgbClr val="007348"/>
                 </a:solidFill>
-                <a:latin typeface="Segoe UI" pitchFamily="34" charset="0"/>
-                <a:ea typeface="Segoe UI" pitchFamily="34" charset="-122"/>
-                <a:cs typeface="Segoe UI" pitchFamily="34" charset="-120"/>
+                <a:latin typeface="Arial" pitchFamily="34" charset="0"/>
+                <a:ea typeface="Arial" pitchFamily="34" charset="-122"/>
+                <a:cs typeface="Arial" pitchFamily="34" charset="-120"/>
               </a:rPr>
               <a:t>  Business rules  </a:t>
             </a:r>
@@ -2970,9 +2970,9 @@
                 <a:solidFill>
                   <a:srgbClr val="FFFFFF"/>
                 </a:solidFill>
-                <a:latin typeface="Segoe UI" pitchFamily="34" charset="0"/>
-                <a:ea typeface="Segoe UI" pitchFamily="34" charset="-122"/>
-                <a:cs typeface="Segoe UI" pitchFamily="34" charset="-120"/>
+                <a:latin typeface="Arial" pitchFamily="34" charset="0"/>
+                <a:ea typeface="Arial" pitchFamily="34" charset="-122"/>
+                <a:cs typeface="Arial" pitchFamily="34" charset="-120"/>
               </a:rPr>
               <a:t>⮎</a:t>
             </a:r>
@@ -3009,9 +3009,9 @@
                 <a:solidFill>
                   <a:srgbClr val="15241D"/>
                 </a:solidFill>
-                <a:latin typeface="Segoe UI" pitchFamily="34" charset="0"/>
-                <a:ea typeface="Segoe UI" pitchFamily="34" charset="-122"/>
-                <a:cs typeface="Segoe UI" pitchFamily="34" charset="-120"/>
+                <a:latin typeface="Arial" pitchFamily="34" charset="0"/>
+                <a:ea typeface="Arial" pitchFamily="34" charset="-122"/>
+                <a:cs typeface="Arial" pitchFamily="34" charset="-120"/>
               </a:rPr>
               <a:t>Process &amp; state machines</a:t>
             </a:r>
@@ -3051,9 +3051,9 @@
                 <a:solidFill>
                   <a:srgbClr val="5B6B63"/>
                 </a:solidFill>
-                <a:latin typeface="Segoe UI" pitchFamily="34" charset="0"/>
-                <a:ea typeface="Segoe UI" pitchFamily="34" charset="-122"/>
-                <a:cs typeface="Segoe UI" pitchFamily="34" charset="-120"/>
+                <a:latin typeface="Arial" pitchFamily="34" charset="0"/>
+                <a:ea typeface="Arial" pitchFamily="34" charset="-122"/>
+                <a:cs typeface="Arial" pitchFamily="34" charset="-120"/>
               </a:rPr>
               <a:t>Model an entity's lifecycle — states, transitions, guards and the actions/events fired along the way. Behaviour, not just structure.</a:t>
             </a:r>
@@ -3090,9 +3090,9 @@
                 <a:solidFill>
                   <a:srgbClr val="007348"/>
                 </a:solidFill>
-                <a:latin typeface="Segoe UI" pitchFamily="34" charset="0"/>
-                <a:ea typeface="Segoe UI" pitchFamily="34" charset="-122"/>
-                <a:cs typeface="Segoe UI" pitchFamily="34" charset="-120"/>
+                <a:latin typeface="Arial" pitchFamily="34" charset="0"/>
+                <a:ea typeface="Arial" pitchFamily="34" charset="-122"/>
+                <a:cs typeface="Arial" pitchFamily="34" charset="-120"/>
               </a:rPr>
               <a:t>  State machines  </a:t>
             </a:r>
@@ -3104,9 +3104,9 @@
                 <a:solidFill>
                   <a:srgbClr val="000000"/>
                 </a:solidFill>
-                <a:latin typeface="Segoe UI" pitchFamily="34" charset="0"/>
-                <a:ea typeface="Segoe UI" pitchFamily="34" charset="-122"/>
-                <a:cs typeface="Segoe UI" pitchFamily="34" charset="-120"/>
+                <a:latin typeface="Arial" pitchFamily="34" charset="0"/>
+                <a:ea typeface="Arial" pitchFamily="34" charset="-122"/>
+                <a:cs typeface="Arial" pitchFamily="34" charset="-120"/>
               </a:rPr>
               <a:t> </a:t>
             </a:r>
@@ -3118,9 +3118,9 @@
                 <a:solidFill>
                   <a:srgbClr val="007348"/>
                 </a:solidFill>
-                <a:latin typeface="Segoe UI" pitchFamily="34" charset="0"/>
-                <a:ea typeface="Segoe UI" pitchFamily="34" charset="-122"/>
-                <a:cs typeface="Segoe UI" pitchFamily="34" charset="-120"/>
+                <a:latin typeface="Arial" pitchFamily="34" charset="0"/>
+                <a:ea typeface="Arial" pitchFamily="34" charset="-122"/>
+                <a:cs typeface="Arial" pitchFamily="34" charset="-120"/>
               </a:rPr>
               <a:t>  Transitions  </a:t>
             </a:r>
@@ -3132,9 +3132,9 @@
                 <a:solidFill>
                   <a:srgbClr val="000000"/>
                 </a:solidFill>
-                <a:latin typeface="Segoe UI" pitchFamily="34" charset="0"/>
-                <a:ea typeface="Segoe UI" pitchFamily="34" charset="-122"/>
-                <a:cs typeface="Segoe UI" pitchFamily="34" charset="-120"/>
+                <a:latin typeface="Arial" pitchFamily="34" charset="0"/>
+                <a:ea typeface="Arial" pitchFamily="34" charset="-122"/>
+                <a:cs typeface="Arial" pitchFamily="34" charset="-120"/>
               </a:rPr>
               <a:t> </a:t>
             </a:r>
@@ -3146,9 +3146,9 @@
                 <a:solidFill>
                   <a:srgbClr val="007348"/>
                 </a:solidFill>
-                <a:latin typeface="Segoe UI" pitchFamily="34" charset="0"/>
-                <a:ea typeface="Segoe UI" pitchFamily="34" charset="-122"/>
-                <a:cs typeface="Segoe UI" pitchFamily="34" charset="-120"/>
+                <a:latin typeface="Arial" pitchFamily="34" charset="0"/>
+                <a:ea typeface="Arial" pitchFamily="34" charset="-122"/>
+                <a:cs typeface="Arial" pitchFamily="34" charset="-120"/>
               </a:rPr>
               <a:t>  Actions  </a:t>
             </a:r>
@@ -3208,9 +3208,9 @@
                 <a:solidFill>
                   <a:srgbClr val="15241D"/>
                 </a:solidFill>
-                <a:latin typeface="Segoe UI" pitchFamily="34" charset="0"/>
-                <a:ea typeface="Segoe UI" pitchFamily="34" charset="-122"/>
-                <a:cs typeface="Segoe UI" pitchFamily="34" charset="-120"/>
+                <a:latin typeface="Arial" pitchFamily="34" charset="0"/>
+                <a:ea typeface="Arial" pitchFamily="34" charset="-122"/>
+                <a:cs typeface="Arial" pitchFamily="34" charset="-120"/>
               </a:rPr>
               <a:t>Smart Data Dictionary</a:t>
             </a:r>
@@ -3222,9 +3222,9 @@
                 <a:solidFill>
                   <a:srgbClr val="5B6B63"/>
                 </a:solidFill>
-                <a:latin typeface="Segoe UI" pitchFamily="34" charset="0"/>
-                <a:ea typeface="Segoe UI" pitchFamily="34" charset="-122"/>
-                <a:cs typeface="Segoe UI" pitchFamily="34" charset="-120"/>
+                <a:latin typeface="Arial" pitchFamily="34" charset="0"/>
+                <a:ea typeface="Arial" pitchFamily="34" charset="-122"/>
+                <a:cs typeface="Arial" pitchFamily="34" charset="-120"/>
               </a:rPr>
               <a:t>  ·  Prepared for BNP Paribas</a:t>
             </a:r>
@@ -3261,9 +3261,9 @@
                 <a:solidFill>
                   <a:srgbClr val="5B6B63"/>
                 </a:solidFill>
-                <a:latin typeface="Segoe UI" pitchFamily="34" charset="0"/>
-                <a:ea typeface="Segoe UI" pitchFamily="34" charset="-122"/>
-                <a:cs typeface="Segoe UI" pitchFamily="34" charset="-120"/>
+                <a:latin typeface="Arial" pitchFamily="34" charset="0"/>
+                <a:ea typeface="Arial" pitchFamily="34" charset="-122"/>
+                <a:cs typeface="Arial" pitchFamily="34" charset="-120"/>
               </a:rPr>
               <a:t>3 / 5</a:t>
             </a:r>
@@ -3332,9 +3332,9 @@
                 <a:solidFill>
                   <a:srgbClr val="00965E"/>
                 </a:solidFill>
-                <a:latin typeface="Segoe UI" pitchFamily="34" charset="0"/>
-                <a:ea typeface="Segoe UI" pitchFamily="34" charset="-122"/>
-                <a:cs typeface="Segoe UI" pitchFamily="34" charset="-120"/>
+                <a:latin typeface="Arial" pitchFamily="34" charset="0"/>
+                <a:ea typeface="Arial" pitchFamily="34" charset="-122"/>
+                <a:cs typeface="Arial" pitchFamily="34" charset="-120"/>
               </a:rPr>
               <a:t>A PLATFORM, NOT A DRAWING</a:t>
             </a:r>
@@ -3371,9 +3371,9 @@
                 <a:solidFill>
                   <a:srgbClr val="15241D"/>
                 </a:solidFill>
-                <a:latin typeface="Segoe UI" pitchFamily="34" charset="0"/>
-                <a:ea typeface="Segoe UI" pitchFamily="34" charset="-122"/>
-                <a:cs typeface="Segoe UI" pitchFamily="34" charset="-120"/>
+                <a:latin typeface="Arial" pitchFamily="34" charset="0"/>
+                <a:ea typeface="Arial" pitchFamily="34" charset="-122"/>
+                <a:cs typeface="Arial" pitchFamily="34" charset="-120"/>
               </a:rPr>
               <a:t>Built for governance at scale</a:t>
             </a:r>
@@ -3459,9 +3459,9 @@
                 <a:solidFill>
                   <a:srgbClr val="00965E"/>
                 </a:solidFill>
-                <a:latin typeface="Segoe UI" pitchFamily="34" charset="0"/>
-                <a:ea typeface="Segoe UI" pitchFamily="34" charset="-122"/>
-                <a:cs typeface="Segoe UI" pitchFamily="34" charset="-120"/>
+                <a:latin typeface="Arial" pitchFamily="34" charset="0"/>
+                <a:ea typeface="Arial" pitchFamily="34" charset="-122"/>
+                <a:cs typeface="Arial" pitchFamily="34" charset="-120"/>
               </a:rPr>
               <a:t>✦</a:t>
             </a:r>
@@ -3498,9 +3498,9 @@
                 <a:solidFill>
                   <a:srgbClr val="15241D"/>
                 </a:solidFill>
-                <a:latin typeface="Segoe UI" pitchFamily="34" charset="0"/>
-                <a:ea typeface="Segoe UI" pitchFamily="34" charset="-122"/>
-                <a:cs typeface="Segoe UI" pitchFamily="34" charset="-120"/>
+                <a:latin typeface="Arial" pitchFamily="34" charset="0"/>
+                <a:ea typeface="Arial" pitchFamily="34" charset="-122"/>
+                <a:cs typeface="Arial" pitchFamily="34" charset="-120"/>
               </a:rPr>
               <a:t>Interactive visualization</a:t>
             </a:r>
@@ -3540,9 +3540,9 @@
                 <a:solidFill>
                   <a:srgbClr val="5B6B63"/>
                 </a:solidFill>
-                <a:latin typeface="Segoe UI" pitchFamily="34" charset="0"/>
-                <a:ea typeface="Segoe UI" pitchFamily="34" charset="-122"/>
-                <a:cs typeface="Segoe UI" pitchFamily="34" charset="-120"/>
+                <a:latin typeface="Arial" pitchFamily="34" charset="0"/>
+                <a:ea typeface="Arial" pitchFamily="34" charset="-122"/>
+                <a:cs typeface="Arial" pitchFamily="34" charset="-120"/>
               </a:rPr>
               <a:t>Explore entities &amp; relationships as a live graph, by package or across the whole model.</a:t>
             </a:r>
@@ -3628,9 +3628,9 @@
                 <a:solidFill>
                   <a:srgbClr val="00965E"/>
                 </a:solidFill>
-                <a:latin typeface="Segoe UI" pitchFamily="34" charset="0"/>
-                <a:ea typeface="Segoe UI" pitchFamily="34" charset="-122"/>
-                <a:cs typeface="Segoe UI" pitchFamily="34" charset="-120"/>
+                <a:latin typeface="Arial" pitchFamily="34" charset="0"/>
+                <a:ea typeface="Arial" pitchFamily="34" charset="-122"/>
+                <a:cs typeface="Arial" pitchFamily="34" charset="-120"/>
               </a:rPr>
               <a:t>✦</a:t>
             </a:r>
@@ -3667,9 +3667,9 @@
                 <a:solidFill>
                   <a:srgbClr val="15241D"/>
                 </a:solidFill>
-                <a:latin typeface="Segoe UI" pitchFamily="34" charset="0"/>
-                <a:ea typeface="Segoe UI" pitchFamily="34" charset="-122"/>
-                <a:cs typeface="Segoe UI" pitchFamily="34" charset="-120"/>
+                <a:latin typeface="Arial" pitchFamily="34" charset="0"/>
+                <a:ea typeface="Arial" pitchFamily="34" charset="-122"/>
+                <a:cs typeface="Arial" pitchFamily="34" charset="-120"/>
               </a:rPr>
               <a:t>Git versioning</a:t>
             </a:r>
@@ -3709,9 +3709,9 @@
                 <a:solidFill>
                   <a:srgbClr val="5B6B63"/>
                 </a:solidFill>
-                <a:latin typeface="Segoe UI" pitchFamily="34" charset="0"/>
-                <a:ea typeface="Segoe UI" pitchFamily="34" charset="-122"/>
-                <a:cs typeface="Segoe UI" pitchFamily="34" charset="-120"/>
+                <a:latin typeface="Arial" pitchFamily="34" charset="0"/>
+                <a:ea typeface="Arial" pitchFamily="34" charset="-122"/>
+                <a:cs typeface="Arial" pitchFamily="34" charset="-120"/>
               </a:rPr>
               <a:t>Every change tracked, diffed, reviewed and published — full history, no database.</a:t>
             </a:r>
@@ -3797,9 +3797,9 @@
                 <a:solidFill>
                   <a:srgbClr val="00965E"/>
                 </a:solidFill>
-                <a:latin typeface="Segoe UI" pitchFamily="34" charset="0"/>
-                <a:ea typeface="Segoe UI" pitchFamily="34" charset="-122"/>
-                <a:cs typeface="Segoe UI" pitchFamily="34" charset="-120"/>
+                <a:latin typeface="Arial" pitchFamily="34" charset="0"/>
+                <a:ea typeface="Arial" pitchFamily="34" charset="-122"/>
+                <a:cs typeface="Arial" pitchFamily="34" charset="-120"/>
               </a:rPr>
               <a:t>✦</a:t>
             </a:r>
@@ -3836,9 +3836,9 @@
                 <a:solidFill>
                   <a:srgbClr val="15241D"/>
                 </a:solidFill>
-                <a:latin typeface="Segoe UI" pitchFamily="34" charset="0"/>
-                <a:ea typeface="Segoe UI" pitchFamily="34" charset="-122"/>
-                <a:cs typeface="Segoe UI" pitchFamily="34" charset="-120"/>
+                <a:latin typeface="Arial" pitchFamily="34" charset="0"/>
+                <a:ea typeface="Arial" pitchFamily="34" charset="-122"/>
+                <a:cs typeface="Arial" pitchFamily="34" charset="-120"/>
               </a:rPr>
               <a:t>Quality &amp; integrity</a:t>
             </a:r>
@@ -3878,9 +3878,9 @@
                 <a:solidFill>
                   <a:srgbClr val="5B6B63"/>
                 </a:solidFill>
-                <a:latin typeface="Segoe UI" pitchFamily="34" charset="0"/>
-                <a:ea typeface="Segoe UI" pitchFamily="34" charset="-122"/>
-                <a:cs typeface="Segoe UI" pitchFamily="34" charset="-120"/>
+                <a:latin typeface="Arial" pitchFamily="34" charset="0"/>
+                <a:ea typeface="Arial" pitchFamily="34" charset="-122"/>
+                <a:cs typeface="Arial" pitchFamily="34" charset="-120"/>
               </a:rPr>
               <a:t>Validation, constraints and business rules in one pane; documentation scoring.</a:t>
             </a:r>
@@ -3966,9 +3966,9 @@
                 <a:solidFill>
                   <a:srgbClr val="00965E"/>
                 </a:solidFill>
-                <a:latin typeface="Segoe UI" pitchFamily="34" charset="0"/>
-                <a:ea typeface="Segoe UI" pitchFamily="34" charset="-122"/>
-                <a:cs typeface="Segoe UI" pitchFamily="34" charset="-120"/>
+                <a:latin typeface="Arial" pitchFamily="34" charset="0"/>
+                <a:ea typeface="Arial" pitchFamily="34" charset="-122"/>
+                <a:cs typeface="Arial" pitchFamily="34" charset="-120"/>
               </a:rPr>
               <a:t>✦</a:t>
             </a:r>
@@ -4005,9 +4005,9 @@
                 <a:solidFill>
                   <a:srgbClr val="15241D"/>
                 </a:solidFill>
-                <a:latin typeface="Segoe UI" pitchFamily="34" charset="0"/>
-                <a:ea typeface="Segoe UI" pitchFamily="34" charset="-122"/>
-                <a:cs typeface="Segoe UI" pitchFamily="34" charset="-120"/>
+                <a:latin typeface="Arial" pitchFamily="34" charset="0"/>
+                <a:ea typeface="Arial" pitchFamily="34" charset="-122"/>
+                <a:cs typeface="Arial" pitchFamily="34" charset="-120"/>
               </a:rPr>
               <a:t>Import &amp; export</a:t>
             </a:r>
@@ -4047,9 +4047,9 @@
                 <a:solidFill>
                   <a:srgbClr val="5B6B63"/>
                 </a:solidFill>
-                <a:latin typeface="Segoe UI" pitchFamily="34" charset="0"/>
-                <a:ea typeface="Segoe UI" pitchFamily="34" charset="-122"/>
-                <a:cs typeface="Segoe UI" pitchFamily="34" charset="-120"/>
+                <a:latin typeface="Arial" pitchFamily="34" charset="0"/>
+                <a:ea typeface="Arial" pitchFamily="34" charset="-122"/>
+                <a:cs typeface="Arial" pitchFamily="34" charset="-120"/>
               </a:rPr>
               <a:t>Export JSON Schema for code-gen; capture physical constraints from SQL DDL / live DBs.</a:t>
             </a:r>
@@ -4135,9 +4135,9 @@
                 <a:solidFill>
                   <a:srgbClr val="00965E"/>
                 </a:solidFill>
-                <a:latin typeface="Segoe UI" pitchFamily="34" charset="0"/>
-                <a:ea typeface="Segoe UI" pitchFamily="34" charset="-122"/>
-                <a:cs typeface="Segoe UI" pitchFamily="34" charset="-120"/>
+                <a:latin typeface="Arial" pitchFamily="34" charset="0"/>
+                <a:ea typeface="Arial" pitchFamily="34" charset="-122"/>
+                <a:cs typeface="Arial" pitchFamily="34" charset="-120"/>
               </a:rPr>
               <a:t>✦</a:t>
             </a:r>
@@ -4174,9 +4174,9 @@
                 <a:solidFill>
                   <a:srgbClr val="15241D"/>
                 </a:solidFill>
-                <a:latin typeface="Segoe UI" pitchFamily="34" charset="0"/>
-                <a:ea typeface="Segoe UI" pitchFamily="34" charset="-122"/>
-                <a:cs typeface="Segoe UI" pitchFamily="34" charset="-120"/>
+                <a:latin typeface="Arial" pitchFamily="34" charset="0"/>
+                <a:ea typeface="Arial" pitchFamily="34" charset="-122"/>
+                <a:cs typeface="Arial" pitchFamily="34" charset="-120"/>
               </a:rPr>
               <a:t>AI assistance</a:t>
             </a:r>
@@ -4216,9 +4216,9 @@
                 <a:solidFill>
                   <a:srgbClr val="5B6B63"/>
                 </a:solidFill>
-                <a:latin typeface="Segoe UI" pitchFamily="34" charset="0"/>
-                <a:ea typeface="Segoe UI" pitchFamily="34" charset="-122"/>
-                <a:cs typeface="Segoe UI" pitchFamily="34" charset="-120"/>
+                <a:latin typeface="Arial" pitchFamily="34" charset="0"/>
+                <a:ea typeface="Arial" pitchFamily="34" charset="-122"/>
+                <a:cs typeface="Arial" pitchFamily="34" charset="-120"/>
               </a:rPr>
               <a:t>In-app chat grounded in your model — author, search and explain, with MCP tools.</a:t>
             </a:r>
@@ -4304,9 +4304,9 @@
                 <a:solidFill>
                   <a:srgbClr val="00965E"/>
                 </a:solidFill>
-                <a:latin typeface="Segoe UI" pitchFamily="34" charset="0"/>
-                <a:ea typeface="Segoe UI" pitchFamily="34" charset="-122"/>
-                <a:cs typeface="Segoe UI" pitchFamily="34" charset="-120"/>
+                <a:latin typeface="Arial" pitchFamily="34" charset="0"/>
+                <a:ea typeface="Arial" pitchFamily="34" charset="-122"/>
+                <a:cs typeface="Arial" pitchFamily="34" charset="-120"/>
               </a:rPr>
               <a:t>✦</a:t>
             </a:r>
@@ -4343,9 +4343,9 @@
                 <a:solidFill>
                   <a:srgbClr val="15241D"/>
                 </a:solidFill>
-                <a:latin typeface="Segoe UI" pitchFamily="34" charset="0"/>
-                <a:ea typeface="Segoe UI" pitchFamily="34" charset="-122"/>
-                <a:cs typeface="Segoe UI" pitchFamily="34" charset="-120"/>
+                <a:latin typeface="Arial" pitchFamily="34" charset="0"/>
+                <a:ea typeface="Arial" pitchFamily="34" charset="-122"/>
+                <a:cs typeface="Arial" pitchFamily="34" charset="-120"/>
               </a:rPr>
               <a:t>CI validation</a:t>
             </a:r>
@@ -4385,9 +4385,9 @@
                 <a:solidFill>
                   <a:srgbClr val="5B6B63"/>
                 </a:solidFill>
-                <a:latin typeface="Segoe UI" pitchFamily="34" charset="0"/>
-                <a:ea typeface="Segoe UI" pitchFamily="34" charset="-122"/>
-                <a:cs typeface="Segoe UI" pitchFamily="34" charset="-120"/>
+                <a:latin typeface="Arial" pitchFamily="34" charset="0"/>
+                <a:ea typeface="Arial" pitchFamily="34" charset="-122"/>
+                <a:cs typeface="Arial" pitchFamily="34" charset="-120"/>
               </a:rPr>
               <a:t>npx … --validate catches model errors before they ever reach the app.</a:t>
             </a:r>
@@ -4447,9 +4447,9 @@
                 <a:solidFill>
                   <a:srgbClr val="15241D"/>
                 </a:solidFill>
-                <a:latin typeface="Segoe UI" pitchFamily="34" charset="0"/>
-                <a:ea typeface="Segoe UI" pitchFamily="34" charset="-122"/>
-                <a:cs typeface="Segoe UI" pitchFamily="34" charset="-120"/>
+                <a:latin typeface="Arial" pitchFamily="34" charset="0"/>
+                <a:ea typeface="Arial" pitchFamily="34" charset="-122"/>
+                <a:cs typeface="Arial" pitchFamily="34" charset="-120"/>
               </a:rPr>
               <a:t>Smart Data Dictionary</a:t>
             </a:r>
@@ -4461,9 +4461,9 @@
                 <a:solidFill>
                   <a:srgbClr val="5B6B63"/>
                 </a:solidFill>
-                <a:latin typeface="Segoe UI" pitchFamily="34" charset="0"/>
-                <a:ea typeface="Segoe UI" pitchFamily="34" charset="-122"/>
-                <a:cs typeface="Segoe UI" pitchFamily="34" charset="-120"/>
+                <a:latin typeface="Arial" pitchFamily="34" charset="0"/>
+                <a:ea typeface="Arial" pitchFamily="34" charset="-122"/>
+                <a:cs typeface="Arial" pitchFamily="34" charset="-120"/>
               </a:rPr>
               <a:t>  ·  Prepared for BNP Paribas</a:t>
             </a:r>
@@ -4500,9 +4500,9 @@
                 <a:solidFill>
                   <a:srgbClr val="5B6B63"/>
                 </a:solidFill>
-                <a:latin typeface="Segoe UI" pitchFamily="34" charset="0"/>
-                <a:ea typeface="Segoe UI" pitchFamily="34" charset="-122"/>
-                <a:cs typeface="Segoe UI" pitchFamily="34" charset="-120"/>
+                <a:latin typeface="Arial" pitchFamily="34" charset="0"/>
+                <a:ea typeface="Arial" pitchFamily="34" charset="-122"/>
+                <a:cs typeface="Arial" pitchFamily="34" charset="-120"/>
               </a:rPr>
               <a:t>4 / 5</a:t>
             </a:r>
@@ -4571,9 +4571,9 @@
                 <a:solidFill>
                   <a:srgbClr val="00965E"/>
                 </a:solidFill>
-                <a:latin typeface="Segoe UI" pitchFamily="34" charset="0"/>
-                <a:ea typeface="Segoe UI" pitchFamily="34" charset="-122"/>
-                <a:cs typeface="Segoe UI" pitchFamily="34" charset="-120"/>
+                <a:latin typeface="Arial" pitchFamily="34" charset="0"/>
+                <a:ea typeface="Arial" pitchFamily="34" charset="-122"/>
+                <a:cs typeface="Arial" pitchFamily="34" charset="-120"/>
               </a:rPr>
               <a:t>HOW IT WORKS</a:t>
             </a:r>
@@ -4610,9 +4610,9 @@
                 <a:solidFill>
                   <a:srgbClr val="15241D"/>
                 </a:solidFill>
-                <a:latin typeface="Segoe UI" pitchFamily="34" charset="0"/>
-                <a:ea typeface="Segoe UI" pitchFamily="34" charset="-122"/>
-                <a:cs typeface="Segoe UI" pitchFamily="34" charset="-120"/>
+                <a:latin typeface="Arial" pitchFamily="34" charset="0"/>
+                <a:ea typeface="Arial" pitchFamily="34" charset="-122"/>
+                <a:cs typeface="Arial" pitchFamily="34" charset="-120"/>
               </a:rPr>
               <a:t>Lightweight to run, ready to scale</a:t>
             </a:r>
@@ -4676,9 +4676,9 @@
                 <a:solidFill>
                   <a:srgbClr val="00965E"/>
                 </a:solidFill>
-                <a:latin typeface="Segoe UI" pitchFamily="34" charset="0"/>
-                <a:ea typeface="Segoe UI" pitchFamily="34" charset="-122"/>
-                <a:cs typeface="Segoe UI" pitchFamily="34" charset="-120"/>
+                <a:latin typeface="Arial" pitchFamily="34" charset="0"/>
+                <a:ea typeface="Arial" pitchFamily="34" charset="-122"/>
+                <a:cs typeface="Arial" pitchFamily="34" charset="-120"/>
               </a:rPr>
               <a:t>01 · STORE</a:t>
             </a:r>
@@ -4715,9 +4715,9 @@
                 <a:solidFill>
                   <a:srgbClr val="15241D"/>
                 </a:solidFill>
-                <a:latin typeface="Segoe UI" pitchFamily="34" charset="0"/>
-                <a:ea typeface="Segoe UI" pitchFamily="34" charset="-122"/>
-                <a:cs typeface="Segoe UI" pitchFamily="34" charset="-120"/>
+                <a:latin typeface="Arial" pitchFamily="34" charset="0"/>
+                <a:ea typeface="Arial" pitchFamily="34" charset="-122"/>
+                <a:cs typeface="Arial" pitchFamily="34" charset="-120"/>
               </a:rPr>
               <a:t>File-based &amp; git-native</a:t>
             </a:r>
@@ -4757,9 +4757,9 @@
                 <a:solidFill>
                   <a:srgbClr val="5B6B63"/>
                 </a:solidFill>
-                <a:latin typeface="Segoe UI" pitchFamily="34" charset="0"/>
-                <a:ea typeface="Segoe UI" pitchFamily="34" charset="-122"/>
-                <a:cs typeface="Segoe UI" pitchFamily="34" charset="-120"/>
+                <a:latin typeface="Arial" pitchFamily="34" charset="0"/>
+                <a:ea typeface="Arial" pitchFamily="34" charset="-122"/>
+                <a:cs typeface="Arial" pitchFamily="34" charset="-120"/>
               </a:rPr>
               <a:t>The model lives as YAML/JSON in a project folder, versioned with git. No database to operate.</a:t>
             </a:r>
@@ -4823,9 +4823,9 @@
                 <a:solidFill>
                   <a:srgbClr val="00965E"/>
                 </a:solidFill>
-                <a:latin typeface="Segoe UI" pitchFamily="34" charset="0"/>
-                <a:ea typeface="Segoe UI" pitchFamily="34" charset="-122"/>
-                <a:cs typeface="Segoe UI" pitchFamily="34" charset="-120"/>
+                <a:latin typeface="Arial" pitchFamily="34" charset="0"/>
+                <a:ea typeface="Arial" pitchFamily="34" charset="-122"/>
+                <a:cs typeface="Arial" pitchFamily="34" charset="-120"/>
               </a:rPr>
               <a:t>02 · RUN</a:t>
             </a:r>
@@ -4862,9 +4862,9 @@
                 <a:solidFill>
                   <a:srgbClr val="15241D"/>
                 </a:solidFill>
-                <a:latin typeface="Segoe UI" pitchFamily="34" charset="0"/>
-                <a:ea typeface="Segoe UI" pitchFamily="34" charset="-122"/>
-                <a:cs typeface="Segoe UI" pitchFamily="34" charset="-120"/>
+                <a:latin typeface="Arial" pitchFamily="34" charset="0"/>
+                <a:ea typeface="Arial" pitchFamily="34" charset="-122"/>
+                <a:cs typeface="Arial" pitchFamily="34" charset="-120"/>
               </a:rPr>
               <a:t>Desktop or server</a:t>
             </a:r>
@@ -4904,9 +4904,9 @@
                 <a:solidFill>
                   <a:srgbClr val="5B6B63"/>
                 </a:solidFill>
-                <a:latin typeface="Segoe UI" pitchFamily="34" charset="0"/>
-                <a:ea typeface="Segoe UI" pitchFamily="34" charset="-122"/>
-                <a:cs typeface="Segoe UI" pitchFamily="34" charset="-120"/>
+                <a:latin typeface="Arial" pitchFamily="34" charset="0"/>
+                <a:ea typeface="Arial" pitchFamily="34" charset="-122"/>
+                <a:cs typeface="Arial" pitchFamily="34" charset="-120"/>
               </a:rPr>
               <a:t>Single-user desktop, or a shared multi-user server with roles (admin / editor / viewer).</a:t>
             </a:r>
@@ -4970,9 +4970,9 @@
                 <a:solidFill>
                   <a:srgbClr val="00965E"/>
                 </a:solidFill>
-                <a:latin typeface="Segoe UI" pitchFamily="34" charset="0"/>
-                <a:ea typeface="Segoe UI" pitchFamily="34" charset="-122"/>
-                <a:cs typeface="Segoe UI" pitchFamily="34" charset="-120"/>
+                <a:latin typeface="Arial" pitchFamily="34" charset="0"/>
+                <a:ea typeface="Arial" pitchFamily="34" charset="-122"/>
+                <a:cs typeface="Arial" pitchFamily="34" charset="-120"/>
               </a:rPr>
               <a:t>03 · GOVERN</a:t>
             </a:r>
@@ -5009,9 +5009,9 @@
                 <a:solidFill>
                   <a:srgbClr val="15241D"/>
                 </a:solidFill>
-                <a:latin typeface="Segoe UI" pitchFamily="34" charset="0"/>
-                <a:ea typeface="Segoe UI" pitchFamily="34" charset="-122"/>
-                <a:cs typeface="Segoe UI" pitchFamily="34" charset="-120"/>
+                <a:latin typeface="Arial" pitchFamily="34" charset="0"/>
+                <a:ea typeface="Arial" pitchFamily="34" charset="-122"/>
+                <a:cs typeface="Arial" pitchFamily="34" charset="-120"/>
               </a:rPr>
               <a:t>Review &amp; publish</a:t>
             </a:r>
@@ -5051,9 +5051,9 @@
                 <a:solidFill>
                   <a:srgbClr val="5B6B63"/>
                 </a:solidFill>
-                <a:latin typeface="Segoe UI" pitchFamily="34" charset="0"/>
-                <a:ea typeface="Segoe UI" pitchFamily="34" charset="-122"/>
-                <a:cs typeface="Segoe UI" pitchFamily="34" charset="-120"/>
+                <a:latin typeface="Arial" pitchFamily="34" charset="0"/>
+                <a:ea typeface="Arial" pitchFamily="34" charset="-122"/>
+                <a:cs typeface="Arial" pitchFamily="34" charset="-120"/>
               </a:rPr>
               <a:t>Draft → review → approve workflows, quality &amp; integrity gates, impact analysis.</a:t>
             </a:r>
@@ -5112,9 +5112,9 @@
                 <a:solidFill>
                   <a:srgbClr val="FFFFFF"/>
                 </a:solidFill>
-                <a:latin typeface="Segoe UI" pitchFamily="34" charset="0"/>
-                <a:ea typeface="Segoe UI" pitchFamily="34" charset="-122"/>
-                <a:cs typeface="Segoe UI" pitchFamily="34" charset="-120"/>
+                <a:latin typeface="Arial" pitchFamily="34" charset="0"/>
+                <a:ea typeface="Arial" pitchFamily="34" charset="-122"/>
+                <a:cs typeface="Arial" pitchFamily="34" charset="-120"/>
               </a:rPr>
               <a:t>Try it in one command   </a:t>
             </a:r>
@@ -5126,9 +5126,9 @@
                 <a:solidFill>
                   <a:srgbClr val="EAFFF5"/>
                 </a:solidFill>
-                <a:latin typeface="Consolas" pitchFamily="34" charset="0"/>
-                <a:ea typeface="Consolas" pitchFamily="34" charset="-122"/>
-                <a:cs typeface="Consolas" pitchFamily="34" charset="-120"/>
+                <a:latin typeface="Courier New" pitchFamily="34" charset="0"/>
+                <a:ea typeface="Courier New" pitchFamily="34" charset="-122"/>
+                <a:cs typeface="Courier New" pitchFamily="34" charset="-120"/>
               </a:rPr>
               <a:t>npx @hamak/smart-data-dico</a:t>
             </a:r>
@@ -5165,9 +5165,9 @@
                 <a:solidFill>
                   <a:srgbClr val="DFF7EC"/>
                 </a:solidFill>
-                <a:latin typeface="Segoe UI" pitchFamily="34" charset="0"/>
-                <a:ea typeface="Segoe UI" pitchFamily="34" charset="-122"/>
-                <a:cs typeface="Segoe UI" pitchFamily="34" charset="-120"/>
+                <a:latin typeface="Arial" pitchFamily="34" charset="0"/>
+                <a:ea typeface="Arial" pitchFamily="34" charset="-122"/>
+                <a:cs typeface="Arial" pitchFamily="34" charset="-120"/>
               </a:rPr>
               <a:t>Bring visibility, governance and shared understanding to BNP Paribas’s complex systems.</a:t>
             </a:r>
@@ -5227,9 +5227,9 @@
                 <a:solidFill>
                   <a:srgbClr val="15241D"/>
                 </a:solidFill>
-                <a:latin typeface="Segoe UI" pitchFamily="34" charset="0"/>
-                <a:ea typeface="Segoe UI" pitchFamily="34" charset="-122"/>
-                <a:cs typeface="Segoe UI" pitchFamily="34" charset="-120"/>
+                <a:latin typeface="Arial" pitchFamily="34" charset="0"/>
+                <a:ea typeface="Arial" pitchFamily="34" charset="-122"/>
+                <a:cs typeface="Arial" pitchFamily="34" charset="-120"/>
               </a:rPr>
               <a:t>Smart Data Dictionary</a:t>
             </a:r>
@@ -5241,9 +5241,9 @@
                 <a:solidFill>
                   <a:srgbClr val="5B6B63"/>
                 </a:solidFill>
-                <a:latin typeface="Segoe UI" pitchFamily="34" charset="0"/>
-                <a:ea typeface="Segoe UI" pitchFamily="34" charset="-122"/>
-                <a:cs typeface="Segoe UI" pitchFamily="34" charset="-120"/>
+                <a:latin typeface="Arial" pitchFamily="34" charset="0"/>
+                <a:ea typeface="Arial" pitchFamily="34" charset="-122"/>
+                <a:cs typeface="Arial" pitchFamily="34" charset="-120"/>
               </a:rPr>
               <a:t>  ·  Prepared for BNP Paribas</a:t>
             </a:r>
@@ -5280,9 +5280,9 @@
                 <a:solidFill>
                   <a:srgbClr val="5B6B63"/>
                 </a:solidFill>
-                <a:latin typeface="Segoe UI" pitchFamily="34" charset="0"/>
-                <a:ea typeface="Segoe UI" pitchFamily="34" charset="-122"/>
-                <a:cs typeface="Segoe UI" pitchFamily="34" charset="-120"/>
+                <a:latin typeface="Arial" pitchFamily="34" charset="0"/>
+                <a:ea typeface="Arial" pitchFamily="34" charset="-122"/>
+                <a:cs typeface="Arial" pitchFamily="34" charset="-120"/>
               </a:rPr>
               <a:t>5 / 5</a:t>
             </a:r>

</xml_diff>